<commit_message>
Update seminar files: remove 02.16, add 02.19 and 02.27, update changed files
</commit_message>
<xml_diff>
--- a/assets/files/26.03.05.세미나.pptx
+++ b/assets/files/26.03.05.세미나.pptx
@@ -138,6 +138,43 @@
 </p:presentation>
 </file>
 
+<file path=ppt/changesInfos/changesInfo1.xml><?xml version="1.0" encoding="utf-8"?>
+<pc:chgInfo xmlns:a="http://schemas.openxmlformats.org/drawingml/2006/main" xmlns:r="http://schemas.openxmlformats.org/officeDocument/2006/relationships" xmlns:ac="http://schemas.microsoft.com/office/drawing/2013/main/command" xmlns:pc="http://schemas.microsoft.com/office/powerpoint/2013/main/command">
+  <pc:docChgLst>
+    <pc:chgData name="성우 최" userId="b39b9c6800b01a47" providerId="LiveId" clId="{86918D44-C542-442D-8291-F46EC03904AF}"/>
+    <pc:docChg chg="modSld">
+      <pc:chgData name="성우 최" userId="b39b9c6800b01a47" providerId="LiveId" clId="{86918D44-C542-442D-8291-F46EC03904AF}" dt="2026-05-16T15:53:41.658" v="10" actId="20577"/>
+      <pc:docMkLst>
+        <pc:docMk/>
+      </pc:docMkLst>
+      <pc:sldChg chg="modSp mod">
+        <pc:chgData name="성우 최" userId="b39b9c6800b01a47" providerId="LiveId" clId="{86918D44-C542-442D-8291-F46EC03904AF}" dt="2026-05-16T15:53:41.658" v="10" actId="20577"/>
+        <pc:sldMkLst>
+          <pc:docMk/>
+          <pc:sldMk cId="3698702118" sldId="257"/>
+        </pc:sldMkLst>
+        <pc:spChg chg="mod">
+          <ac:chgData name="성우 최" userId="b39b9c6800b01a47" providerId="LiveId" clId="{86918D44-C542-442D-8291-F46EC03904AF}" dt="2026-05-16T15:53:41.658" v="10" actId="20577"/>
+          <ac:spMkLst>
+            <pc:docMk/>
+            <pc:sldMk cId="3698702118" sldId="257"/>
+            <ac:spMk id="2" creationId="{039EC387-777F-15BD-C1A9-44BD066BBF5D}"/>
+          </ac:spMkLst>
+        </pc:spChg>
+        <pc:spChg chg="mod">
+          <ac:chgData name="성우 최" userId="b39b9c6800b01a47" providerId="LiveId" clId="{86918D44-C542-442D-8291-F46EC03904AF}" dt="2026-05-16T15:50:56.512" v="5" actId="20577"/>
+          <ac:spMkLst>
+            <pc:docMk/>
+            <pc:sldMk cId="3698702118" sldId="257"/>
+            <ac:spMk id="3" creationId="{30EB2FD9-9788-7FA6-F8A9-48CFEE6E33FF}"/>
+          </ac:spMkLst>
+        </pc:spChg>
+      </pc:sldChg>
+    </pc:docChg>
+  </pc:docChgLst>
+</pc:chgInfo>
+</file>
+
 <file path=ppt/slideLayouts/slideLayout1.xml><?xml version="1.0" encoding="utf-8"?>
 <p:sldLayout xmlns:a="http://schemas.openxmlformats.org/drawingml/2006/main" xmlns:r="http://schemas.openxmlformats.org/officeDocument/2006/relationships" xmlns:p="http://schemas.openxmlformats.org/presentationml/2006/main" showMasterSp="0" type="title" preserve="1">
   <p:cSld name="제목 슬라이드">
@@ -307,7 +344,7 @@
           <a:p>
             <a:fld id="{EFFE3BE3-E637-41BB-B5A2-116DFFD46B72}" type="datetimeFigureOut">
               <a:rPr lang="ko-KR" altLang="en-US" smtClean="0"/>
-              <a:t>2026-03-03</a:t>
+              <a:t>2026-05-17</a:t>
             </a:fld>
             <a:endParaRPr lang="ko-KR" altLang="en-US"/>
           </a:p>
@@ -651,7 +688,7 @@
           <a:p>
             <a:fld id="{EFFE3BE3-E637-41BB-B5A2-116DFFD46B72}" type="datetimeFigureOut">
               <a:rPr lang="ko-KR" altLang="en-US" smtClean="0"/>
-              <a:t>2026-03-03</a:t>
+              <a:t>2026-05-17</a:t>
             </a:fld>
             <a:endParaRPr lang="ko-KR" altLang="en-US"/>
           </a:p>
@@ -831,7 +868,7 @@
           <a:p>
             <a:fld id="{EFFE3BE3-E637-41BB-B5A2-116DFFD46B72}" type="datetimeFigureOut">
               <a:rPr lang="ko-KR" altLang="en-US" smtClean="0"/>
-              <a:t>2026-03-03</a:t>
+              <a:t>2026-05-17</a:t>
             </a:fld>
             <a:endParaRPr lang="ko-KR" altLang="en-US"/>
           </a:p>
@@ -1001,7 +1038,7 @@
           <a:p>
             <a:fld id="{EFFE3BE3-E637-41BB-B5A2-116DFFD46B72}" type="datetimeFigureOut">
               <a:rPr lang="ko-KR" altLang="en-US" smtClean="0"/>
-              <a:t>2026-03-03</a:t>
+              <a:t>2026-05-17</a:t>
             </a:fld>
             <a:endParaRPr lang="ko-KR" altLang="en-US"/>
           </a:p>
@@ -1278,7 +1315,7 @@
           <a:p>
             <a:fld id="{EFFE3BE3-E637-41BB-B5A2-116DFFD46B72}" type="datetimeFigureOut">
               <a:rPr lang="ko-KR" altLang="en-US" smtClean="0"/>
-              <a:t>2026-03-03</a:t>
+              <a:t>2026-05-17</a:t>
             </a:fld>
             <a:endParaRPr lang="ko-KR" altLang="en-US"/>
           </a:p>
@@ -1672,7 +1709,7 @@
           <a:p>
             <a:fld id="{EFFE3BE3-E637-41BB-B5A2-116DFFD46B72}" type="datetimeFigureOut">
               <a:rPr lang="ko-KR" altLang="en-US" smtClean="0"/>
-              <a:t>2026-03-03</a:t>
+              <a:t>2026-05-17</a:t>
             </a:fld>
             <a:endParaRPr lang="ko-KR" altLang="en-US"/>
           </a:p>
@@ -2149,7 +2186,7 @@
           <a:p>
             <a:fld id="{EFFE3BE3-E637-41BB-B5A2-116DFFD46B72}" type="datetimeFigureOut">
               <a:rPr lang="ko-KR" altLang="en-US" smtClean="0"/>
-              <a:t>2026-03-03</a:t>
+              <a:t>2026-05-17</a:t>
             </a:fld>
             <a:endParaRPr lang="ko-KR" altLang="en-US"/>
           </a:p>
@@ -2267,7 +2304,7 @@
           <a:p>
             <a:fld id="{EFFE3BE3-E637-41BB-B5A2-116DFFD46B72}" type="datetimeFigureOut">
               <a:rPr lang="ko-KR" altLang="en-US" smtClean="0"/>
-              <a:t>2026-03-03</a:t>
+              <a:t>2026-05-17</a:t>
             </a:fld>
             <a:endParaRPr lang="ko-KR" altLang="en-US"/>
           </a:p>
@@ -2362,7 +2399,7 @@
           <a:p>
             <a:fld id="{EFFE3BE3-E637-41BB-B5A2-116DFFD46B72}" type="datetimeFigureOut">
               <a:rPr lang="ko-KR" altLang="en-US" smtClean="0"/>
-              <a:t>2026-03-03</a:t>
+              <a:t>2026-05-17</a:t>
             </a:fld>
             <a:endParaRPr lang="ko-KR" altLang="en-US"/>
           </a:p>
@@ -2708,7 +2745,7 @@
           <a:p>
             <a:fld id="{EFFE3BE3-E637-41BB-B5A2-116DFFD46B72}" type="datetimeFigureOut">
               <a:rPr lang="ko-KR" altLang="en-US" smtClean="0"/>
-              <a:t>2026-03-03</a:t>
+              <a:t>2026-05-17</a:t>
             </a:fld>
             <a:endParaRPr lang="ko-KR" altLang="en-US"/>
           </a:p>
@@ -3096,7 +3133,7 @@
           <a:p>
             <a:fld id="{EFFE3BE3-E637-41BB-B5A2-116DFFD46B72}" type="datetimeFigureOut">
               <a:rPr lang="ko-KR" altLang="en-US" smtClean="0"/>
-              <a:t>2026-03-03</a:t>
+              <a:t>2026-05-17</a:t>
             </a:fld>
             <a:endParaRPr lang="ko-KR" altLang="en-US"/>
           </a:p>
@@ -3374,7 +3411,7 @@
           <a:p>
             <a:fld id="{EFFE3BE3-E637-41BB-B5A2-116DFFD46B72}" type="datetimeFigureOut">
               <a:rPr lang="ko-KR" altLang="en-US" smtClean="0"/>
-              <a:t>2026-03-03</a:t>
+              <a:t>2026-05-17</a:t>
             </a:fld>
             <a:endParaRPr lang="ko-KR" altLang="en-US"/>
           </a:p>
@@ -3922,6 +3959,11 @@
               <a:rPr lang="ko-KR" altLang="en-US" sz="4000" dirty="0"/>
               <a:t>논문 리뷰</a:t>
             </a:r>
+            <a:r>
+              <a:rPr lang="en-US" altLang="ko-KR" sz="4000"/>
+              <a:t>(3)</a:t>
+            </a:r>
+            <a:endParaRPr lang="ko-KR" altLang="en-US" sz="4000" dirty="0"/>
           </a:p>
         </p:txBody>
       </p:sp>
@@ -3947,8 +3989,8 @@
           <a:lstStyle/>
           <a:p>
             <a:r>
-              <a:rPr lang="en-US" altLang="ko-KR"/>
-              <a:t>26.02.27.</a:t>
+              <a:rPr lang="en-US" altLang="ko-KR" dirty="0"/>
+              <a:t>26.03.05.</a:t>
             </a:r>
             <a:r>
               <a:rPr lang="ko-KR" altLang="en-US" dirty="0"/>

</xml_diff>